<commit_message>
docs: polish arrows and formatting in evaluation deck
</commit_message>
<xml_diff>
--- a/docs/Health_Assistant_Evaluation.pptx
+++ b/docs/Health_Assistant_Evaluation.pptx
@@ -10801,7 +10801,7 @@
               </a:defRPr>
             </a:pPr>
             <a:r>
-              <a:t>• NFR3 (Availability &amp; Fault Tolerance): Dual-provider failover (Groq ➔ Gemini) to guarantee 99.9% service uptime under quota exhaustion.</a:t>
+              <a:t>• NFR3 (Availability &amp; Fault Tolerance): Dual-provider failover (Groq -&gt; Gemini) to guarantee 99.9% service uptime under quota exhaustion.</a:t>
             </a:r>
           </a:p>
           <a:p>
@@ -13196,7 +13196,7 @@
               </a:defRPr>
             </a:pPr>
             <a:r>
-              <a:t>   Payload: {session_id, content}  ➔  SSE stream with event types: token, citation, escalation, done</a:t>
+              <a:t>   Payload: {session_id, content}  -&gt;  SSE stream with event types: token, citation, escalation, done</a:t>
             </a:r>
           </a:p>
           <a:p>
@@ -13223,7 +13223,7 @@
               </a:defRPr>
             </a:pPr>
             <a:r>
-              <a:t>   Payload: None  ➔  Returns 200 OK with list of active user chat sessions [SessionOut]</a:t>
+              <a:t>   Payload: None  -&gt;  Returns 200 OK with list of active user chat sessions [SessionOut]</a:t>
             </a:r>
           </a:p>
           <a:p>
@@ -13250,7 +13250,7 @@
               </a:defRPr>
             </a:pPr>
             <a:r>
-              <a:t>   Payload: session_id  ➔  Returns 200 OK with full conversation history &amp; citation IDs [MessageOut]</a:t>
+              <a:t>   Payload: session_id  -&gt;  Returns 200 OK with full conversation history &amp; citation IDs [MessageOut]</a:t>
             </a:r>
           </a:p>
           <a:p>
@@ -13277,7 +13277,7 @@
               </a:defRPr>
             </a:pPr>
             <a:r>
-              <a:t>   Payload: session_id  ➔  Soft-deletes session (sets deleted_at); returns 204 No Content</a:t>
+              <a:t>   Payload: session_id  -&gt;  Soft-deletes session (sets deleted_at); returns 204 No Content</a:t>
             </a:r>
           </a:p>
           <a:p>
@@ -13304,7 +13304,7 @@
               </a:defRPr>
             </a:pPr>
             <a:r>
-              <a:t>   Payload: None  ➔  Returns 200 OK with authenticated Clerk user ID &amp; email (401 if invalid)</a:t>
+              <a:t>   Payload: None  -&gt;  Returns 200 OK with authenticated Clerk user ID &amp; email (401 if invalid)</a:t>
             </a:r>
           </a:p>
           <a:p>
@@ -13331,7 +13331,7 @@
               </a:defRPr>
             </a:pPr>
             <a:r>
-              <a:t>   Payload: None  ➔  Returns 200 OK: {status, database: {reachable, pgvector}, redis: {reachable}}</a:t>
+              <a:t>   Payload: None  -&gt;  Returns 200 OK: {status, database: {reachable, pgvector}, redis: {reachable}}</a:t>
             </a:r>
           </a:p>
         </p:txBody>

</xml_diff>

<commit_message>
docs: add student credentials and guide details to presentation cover page
</commit_message>
<xml_diff>
--- a/docs/Health_Assistant_Evaluation.pptx
+++ b/docs/Health_Assistant_Evaluation.pptx
@@ -770,11 +770,28 @@
           <a:lstStyle/>
           <a:p>
             <a:r>
-              <a:rPr lang="en-US" dirty="0"/>
-              <a:t>Good morning evaluators. Today I am presenting our Grounded AI Health Assistant.
-While general AI models like ChatGPT are fluent, fluent fabrication in medicine can be fatal. Our system is designed around auditable medical provenance (WHO, NHS, NIH, CDC), strict negative constraints, and sub-millisecond emergency short-circuiting.</a:t>
-            </a:r>
-            <a:endParaRPr lang="en-US" dirty="0"/>
+              <a:t>SPEAKER NOTES:</a:t>
+            </a:r>
+          </a:p>
+          <a:p>
+            <a:r>
+              <a:t>Good morning evaluators and respected Guide Prof. C.P. Navdeti. My name is Shardul Shripad Hingane, registration number 2023bit005 from the Department of Information Technology. Today I am presenting our project: Grounded AI Health Assistant &amp; Emergency Triage for our Design Document &amp; Feasibility Analysis evaluation.</a:t>
+            </a:r>
+          </a:p>
+          <a:p>
+            <a:r>
+              <a:t>1. Highlight UN SDG 3 alignment: Target 3.8 — access to verified health information with zero medical misinformation.</a:t>
+            </a:r>
+          </a:p>
+          <a:p>
+            <a:r>
+              <a:t>2. State our core paradigm: strict negative constraints — system refuses to guess without verified sources.</a:t>
+            </a:r>
+          </a:p>
+          <a:p>
+            <a:r>
+              <a:t>3. Point to our safety floor: emergency symptoms bypass AI entirely via a sub-20ms short-circuit.</a:t>
+            </a:r>
           </a:p>
         </p:txBody>
       </p:sp>
@@ -2871,7 +2888,7 @@
         </p:nvSpPr>
         <p:spPr>
           <a:xfrm>
-            <a:off x="640080" y="1051560"/>
+            <a:off x="640080" y="750000"/>
             <a:ext cx="7315200" cy="320040"/>
           </a:xfrm>
           <a:prstGeom prst="rect">
@@ -2910,7 +2927,7 @@
         </p:nvSpPr>
         <p:spPr>
           <a:xfrm>
-            <a:off x="640080" y="1417320"/>
+            <a:off x="640080" y="1100000"/>
             <a:ext cx="10789920" cy="1737360"/>
           </a:xfrm>
           <a:prstGeom prst="rect">
@@ -2972,7 +2989,7 @@
         </p:nvSpPr>
         <p:spPr>
           <a:xfrm>
-            <a:off x="640080" y="3063240"/>
+            <a:off x="640080" y="2700000"/>
             <a:ext cx="9601200" cy="457200"/>
           </a:xfrm>
           <a:prstGeom prst="rect">
@@ -3561,7 +3578,209 @@
               </a:defRPr>
             </a:pPr>
             <a:r>
-              <a:t>Eval date: September 26, 2026 · Milestone: Design Document &amp; Feasibility Analysis · FastAPI · PostgreSQL · React · Clerk</a:t>
+              <a:t>Milestone: Design Document &amp; Feasibility Analysis  ·  FastAPI · PostgreSQL (pgvector) · React · Clerk</a:t>
+            </a:r>
+          </a:p>
+        </p:txBody>
+      </p:sp>
+      <p:sp>
+        <p:nvSpPr>
+          <p:cNvPr id="24" name="Rounded Rectangle 23"/>
+          <p:cNvSpPr/>
+          <p:nvPr/>
+        </p:nvSpPr>
+        <p:spPr>
+          <a:xfrm>
+            <a:off x="640080" y="3180000"/>
+            <a:ext cx="5600000" cy="548640"/>
+          </a:xfrm>
+          <a:prstGeom prst="roundRect">
+            <a:avLst/>
+          </a:prstGeom>
+          <a:solidFill>
+            <a:srgbClr val="22335A"/>
+          </a:solidFill>
+          <a:ln w="12700">
+            <a:solidFill>
+              <a:srgbClr val="3B4F7A"/>
+            </a:solidFill>
+          </a:ln>
+        </p:spPr>
+        <p:style>
+          <a:lnRef idx="1">
+            <a:schemeClr val="accent1"/>
+          </a:lnRef>
+          <a:fillRef idx="3">
+            <a:schemeClr val="accent1"/>
+          </a:fillRef>
+          <a:effectRef idx="2">
+            <a:schemeClr val="accent1"/>
+          </a:effectRef>
+          <a:fontRef idx="minor">
+            <a:schemeClr val="lt1"/>
+          </a:fontRef>
+        </p:style>
+        <p:txBody>
+          <a:bodyPr rtlCol="0" anchor="ctr"/>
+          <a:lstStyle/>
+          <a:p>
+            <a:pPr algn="ctr"/>
+          </a:p>
+        </p:txBody>
+      </p:sp>
+      <p:sp>
+        <p:nvSpPr>
+          <p:cNvPr id="25" name="TextBox 24"/>
+          <p:cNvSpPr txBox="1"/>
+          <p:nvPr/>
+        </p:nvSpPr>
+        <p:spPr>
+          <a:xfrm>
+            <a:off x="800000" y="3210000"/>
+            <a:ext cx="5300000" cy="480000"/>
+          </a:xfrm>
+          <a:prstGeom prst="rect">
+            <a:avLst/>
+          </a:prstGeom>
+          <a:noFill/>
+        </p:spPr>
+        <p:txBody>
+          <a:bodyPr wrap="square">
+            <a:spAutoFit/>
+          </a:bodyPr>
+          <a:lstStyle/>
+          <a:p>
+            <a:r>
+              <a:rPr sz="1350" b="1">
+                <a:solidFill>
+                  <a:srgbClr val="FFFFFF"/>
+                </a:solidFill>
+                <a:latin typeface="Cambria"/>
+              </a:rPr>
+              <a:t>Shardul Shripad Hingane</a:t>
+            </a:r>
+            <a:r>
+              <a:rPr sz="1100">
+                <a:solidFill>
+                  <a:srgbClr val="0F8B8D"/>
+                </a:solidFill>
+                <a:latin typeface="Calibri"/>
+              </a:rPr>
+              <a:t>  (Reg: 2023bit005)</a:t>
+            </a:r>
+          </a:p>
+          <a:p>
+            <a:pPr>
+              <a:defRPr sz="1100">
+                <a:solidFill>
+                  <a:srgbClr val="CBD5E1"/>
+                </a:solidFill>
+                <a:latin typeface="Calibri"/>
+              </a:defRPr>
+            </a:pPr>
+            <a:r>
+              <a:t>Department of Information Technology</a:t>
+            </a:r>
+          </a:p>
+        </p:txBody>
+      </p:sp>
+      <p:sp>
+        <p:nvSpPr>
+          <p:cNvPr id="26" name="Rounded Rectangle 25"/>
+          <p:cNvSpPr/>
+          <p:nvPr/>
+        </p:nvSpPr>
+        <p:spPr>
+          <a:xfrm>
+            <a:off x="6440080" y="3180000"/>
+            <a:ext cx="5081360" cy="548640"/>
+          </a:xfrm>
+          <a:prstGeom prst="roundRect">
+            <a:avLst/>
+          </a:prstGeom>
+          <a:solidFill>
+            <a:srgbClr val="22335A"/>
+          </a:solidFill>
+          <a:ln w="12700">
+            <a:solidFill>
+              <a:srgbClr val="3B4F7A"/>
+            </a:solidFill>
+          </a:ln>
+        </p:spPr>
+        <p:style>
+          <a:lnRef idx="1">
+            <a:schemeClr val="accent1"/>
+          </a:lnRef>
+          <a:fillRef idx="3">
+            <a:schemeClr val="accent1"/>
+          </a:fillRef>
+          <a:effectRef idx="2">
+            <a:schemeClr val="accent1"/>
+          </a:effectRef>
+          <a:fontRef idx="minor">
+            <a:schemeClr val="lt1"/>
+          </a:fontRef>
+        </p:style>
+        <p:txBody>
+          <a:bodyPr rtlCol="0" anchor="ctr"/>
+          <a:lstStyle/>
+          <a:p>
+            <a:pPr algn="ctr"/>
+          </a:p>
+        </p:txBody>
+      </p:sp>
+      <p:sp>
+        <p:nvSpPr>
+          <p:cNvPr id="27" name="TextBox 26"/>
+          <p:cNvSpPr txBox="1"/>
+          <p:nvPr/>
+        </p:nvSpPr>
+        <p:spPr>
+          <a:xfrm>
+            <a:off x="6600000" y="3210000"/>
+            <a:ext cx="4800000" cy="480000"/>
+          </a:xfrm>
+          <a:prstGeom prst="rect">
+            <a:avLst/>
+          </a:prstGeom>
+          <a:noFill/>
+        </p:spPr>
+        <p:txBody>
+          <a:bodyPr wrap="square">
+            <a:spAutoFit/>
+          </a:bodyPr>
+          <a:lstStyle/>
+          <a:p>
+            <a:r>
+              <a:rPr sz="1100">
+                <a:solidFill>
+                  <a:srgbClr val="94A3B8"/>
+                </a:solidFill>
+                <a:latin typeface="Calibri"/>
+              </a:rPr>
+              <a:t>Project Guide: </a:t>
+            </a:r>
+            <a:r>
+              <a:rPr sz="1350" b="1">
+                <a:solidFill>
+                  <a:srgbClr val="FFFFFF"/>
+                </a:solidFill>
+                <a:latin typeface="Cambria"/>
+              </a:rPr>
+              <a:t>C.P. Navdeti</a:t>
+            </a:r>
+          </a:p>
+          <a:p>
+            <a:pPr>
+              <a:defRPr sz="1100">
+                <a:solidFill>
+                  <a:srgbClr val="CBD5E1"/>
+                </a:solidFill>
+                <a:latin typeface="Calibri"/>
+              </a:defRPr>
+            </a:pPr>
+            <a:r>
+              <a:t>Evaluation Date: 26 Sep 2026</a:t>
             </a:r>
           </a:p>
         </p:txBody>

</xml_diff>

<commit_message>
docs: streamline presentation cover page with unified candidate & guide credentials
</commit_message>
<xml_diff>
--- a/docs/Health_Assistant_Evaluation.pptx
+++ b/docs/Health_Assistant_Evaluation.pptx
@@ -2888,7 +2888,7 @@
         </p:nvSpPr>
         <p:spPr>
           <a:xfrm>
-            <a:off x="640080" y="750000"/>
+            <a:off x="640080" y="1051560"/>
             <a:ext cx="7315200" cy="320040"/>
           </a:xfrm>
           <a:prstGeom prst="rect">
@@ -2927,7 +2927,7 @@
         </p:nvSpPr>
         <p:spPr>
           <a:xfrm>
-            <a:off x="640080" y="1100000"/>
+            <a:off x="640080" y="1417320"/>
             <a:ext cx="10789920" cy="1737360"/>
           </a:xfrm>
           <a:prstGeom prst="rect">
@@ -2989,7 +2989,7 @@
         </p:nvSpPr>
         <p:spPr>
           <a:xfrm>
-            <a:off x="640080" y="2700000"/>
+            <a:off x="640080" y="3063240"/>
             <a:ext cx="9601200" cy="457200"/>
           </a:xfrm>
           <a:prstGeom prst="rect">
@@ -3182,340 +3182,6 @@
                 <a:cs typeface="Calibri" pitchFamily="34" charset="-120"/>
               </a:rPr>
               <a:t>Access to safe, verified health information without medical misinformation.</a:t>
-            </a:r>
-            <a:endParaRPr lang="en-US" sz="1150" dirty="0"/>
-          </a:p>
-        </p:txBody>
-      </p:sp>
-      <p:sp>
-        <p:nvSpPr>
-          <p:cNvPr id="12" name="Shape 10"/>
-          <p:cNvSpPr/>
-          <p:nvPr/>
-        </p:nvSpPr>
-        <p:spPr>
-          <a:xfrm>
-            <a:off x="4434840" y="3886200"/>
-            <a:ext cx="3520440" cy="1691640"/>
-          </a:xfrm>
-          <a:prstGeom prst="roundRect">
-            <a:avLst>
-              <a:gd name="adj" fmla="val 4324"/>
-            </a:avLst>
-          </a:prstGeom>
-          <a:solidFill>
-            <a:srgbClr val="22335A"/>
-          </a:solidFill>
-          <a:ln/>
-        </p:spPr>
-        <p:txBody>
-          <a:bodyPr/>
-          <a:p/>
-        </p:txBody>
-      </p:sp>
-      <p:sp>
-        <p:nvSpPr>
-          <p:cNvPr id="13" name="Shape 11"/>
-          <p:cNvSpPr/>
-          <p:nvPr/>
-        </p:nvSpPr>
-        <p:spPr>
-          <a:xfrm>
-            <a:off x="4663440" y="4114800"/>
-            <a:ext cx="457200" cy="457200"/>
-          </a:xfrm>
-          <a:prstGeom prst="ellipse">
-            <a:avLst/>
-          </a:prstGeom>
-          <a:solidFill>
-            <a:srgbClr val="0F8B8D"/>
-          </a:solidFill>
-          <a:ln/>
-        </p:spPr>
-        <p:txBody>
-          <a:bodyPr/>
-          <a:p/>
-        </p:txBody>
-      </p:sp>
-      <p:sp>
-        <p:nvSpPr>
-          <p:cNvPr id="14" name="Text 12"/>
-          <p:cNvSpPr txBox="1"/>
-          <p:nvPr/>
-        </p:nvSpPr>
-        <p:spPr>
-          <a:xfrm>
-            <a:off x="4663440" y="4114800"/>
-            <a:ext cx="457200" cy="457200"/>
-          </a:xfrm>
-          <a:prstGeom prst="rect">
-            <a:avLst/>
-          </a:prstGeom>
-          <a:noFill/>
-          <a:ln/>
-        </p:spPr>
-        <p:txBody>
-          <a:bodyPr wrap="square" lIns="0" tIns="0" rIns="0" bIns="0" rtlCol="0" anchor="ctr"/>
-          <a:lstStyle/>
-          <a:p>
-            <a:pPr algn="ctr" indent="0" marL="0">
-              <a:buNone/>
-            </a:pPr>
-            <a:r>
-              <a:rPr lang="en-US" sz="1200" b="1" dirty="0">
-                <a:solidFill>
-                  <a:srgbClr val="FFFFFF"/>
-                </a:solidFill>
-                <a:latin typeface="Cambria" pitchFamily="34" charset="0"/>
-                <a:ea typeface="Cambria" pitchFamily="34" charset="-122"/>
-                <a:cs typeface="Cambria" pitchFamily="34" charset="-120"/>
-              </a:rPr>
-              <a:t>!</a:t>
-            </a:r>
-            <a:endParaRPr lang="en-US" sz="1200" dirty="0"/>
-          </a:p>
-        </p:txBody>
-      </p:sp>
-      <p:sp>
-        <p:nvSpPr>
-          <p:cNvPr id="15" name="Text 13"/>
-          <p:cNvSpPr txBox="1"/>
-          <p:nvPr/>
-        </p:nvSpPr>
-        <p:spPr>
-          <a:xfrm>
-            <a:off x="5257800" y="4142232"/>
-            <a:ext cx="2514600" cy="365760"/>
-          </a:xfrm>
-          <a:prstGeom prst="rect">
-            <a:avLst/>
-          </a:prstGeom>
-          <a:noFill/>
-          <a:ln/>
-        </p:spPr>
-        <p:txBody>
-          <a:bodyPr wrap="square" lIns="0" tIns="0" rIns="0" bIns="0" rtlCol="0" anchor="ctr"/>
-          <a:lstStyle/>
-          <a:p>
-            <a:pPr indent="0" marL="0">
-              <a:buNone/>
-            </a:pPr>
-            <a:r>
-              <a:rPr lang="en-US" sz="1200" b="1" spc="100" kern="0" dirty="0">
-                <a:solidFill>
-                  <a:srgbClr val="5FD4C7"/>
-                </a:solidFill>
-                <a:latin typeface="Calibri" pitchFamily="34" charset="0"/>
-                <a:ea typeface="Calibri" pitchFamily="34" charset="-122"/>
-                <a:cs typeface="Calibri" pitchFamily="34" charset="-120"/>
-              </a:rPr>
-              <a:t>CORE PARADIGM</a:t>
-            </a:r>
-            <a:endParaRPr lang="en-US" sz="1200" dirty="0"/>
-          </a:p>
-        </p:txBody>
-      </p:sp>
-      <p:sp>
-        <p:nvSpPr>
-          <p:cNvPr id="16" name="Text 14"/>
-          <p:cNvSpPr txBox="1"/>
-          <p:nvPr/>
-        </p:nvSpPr>
-        <p:spPr>
-          <a:xfrm>
-            <a:off x="4663440" y="4663440"/>
-            <a:ext cx="3063240" cy="731520"/>
-          </a:xfrm>
-          <a:prstGeom prst="rect">
-            <a:avLst/>
-          </a:prstGeom>
-          <a:noFill/>
-          <a:ln/>
-        </p:spPr>
-        <p:txBody>
-          <a:bodyPr wrap="square" lIns="0" tIns="0" rIns="0" bIns="0" rtlCol="0" anchor="t"/>
-          <a:lstStyle/>
-          <a:p>
-            <a:pPr indent="0" marL="0">
-              <a:buNone/>
-            </a:pPr>
-            <a:r>
-              <a:rPr lang="en-US" sz="1150" dirty="0">
-                <a:solidFill>
-                  <a:srgbClr val="D7E1F0"/>
-                </a:solidFill>
-                <a:latin typeface="Calibri" pitchFamily="34" charset="0"/>
-                <a:ea typeface="Calibri" pitchFamily="34" charset="-122"/>
-                <a:cs typeface="Calibri" pitchFamily="34" charset="-120"/>
-              </a:rPr>
-              <a:t>Strict negative constraints — refuses to guess without verified sources.</a:t>
-            </a:r>
-            <a:endParaRPr lang="en-US" sz="1150" dirty="0"/>
-          </a:p>
-        </p:txBody>
-      </p:sp>
-      <p:sp>
-        <p:nvSpPr>
-          <p:cNvPr id="17" name="Shape 15"/>
-          <p:cNvSpPr/>
-          <p:nvPr/>
-        </p:nvSpPr>
-        <p:spPr>
-          <a:xfrm>
-            <a:off x="8229600" y="3886200"/>
-            <a:ext cx="3520440" cy="1691640"/>
-          </a:xfrm>
-          <a:prstGeom prst="roundRect">
-            <a:avLst>
-              <a:gd name="adj" fmla="val 4324"/>
-            </a:avLst>
-          </a:prstGeom>
-          <a:solidFill>
-            <a:srgbClr val="22335A"/>
-          </a:solidFill>
-          <a:ln/>
-        </p:spPr>
-        <p:txBody>
-          <a:bodyPr/>
-          <a:p/>
-        </p:txBody>
-      </p:sp>
-      <p:sp>
-        <p:nvSpPr>
-          <p:cNvPr id="18" name="Shape 16"/>
-          <p:cNvSpPr/>
-          <p:nvPr/>
-        </p:nvSpPr>
-        <p:spPr>
-          <a:xfrm>
-            <a:off x="8458200" y="4114800"/>
-            <a:ext cx="457200" cy="457200"/>
-          </a:xfrm>
-          <a:prstGeom prst="ellipse">
-            <a:avLst/>
-          </a:prstGeom>
-          <a:solidFill>
-            <a:srgbClr val="0F8B8D"/>
-          </a:solidFill>
-          <a:ln/>
-        </p:spPr>
-        <p:txBody>
-          <a:bodyPr/>
-          <a:p/>
-        </p:txBody>
-      </p:sp>
-      <p:sp>
-        <p:nvSpPr>
-          <p:cNvPr id="19" name="Text 17"/>
-          <p:cNvSpPr txBox="1"/>
-          <p:nvPr/>
-        </p:nvSpPr>
-        <p:spPr>
-          <a:xfrm>
-            <a:off x="8458200" y="4114800"/>
-            <a:ext cx="457200" cy="457200"/>
-          </a:xfrm>
-          <a:prstGeom prst="rect">
-            <a:avLst/>
-          </a:prstGeom>
-          <a:noFill/>
-          <a:ln/>
-        </p:spPr>
-        <p:txBody>
-          <a:bodyPr wrap="square" lIns="0" tIns="0" rIns="0" bIns="0" rtlCol="0" anchor="ctr"/>
-          <a:lstStyle/>
-          <a:p>
-            <a:pPr algn="ctr" indent="0" marL="0">
-              <a:buNone/>
-            </a:pPr>
-            <a:r>
-              <a:rPr lang="en-US" sz="1200" b="1" dirty="0">
-                <a:solidFill>
-                  <a:srgbClr val="FFFFFF"/>
-                </a:solidFill>
-                <a:latin typeface="Cambria" pitchFamily="34" charset="0"/>
-                <a:ea typeface="Cambria" pitchFamily="34" charset="-122"/>
-                <a:cs typeface="Cambria" pitchFamily="34" charset="-120"/>
-              </a:rPr>
-              <a:t>✓</a:t>
-            </a:r>
-            <a:endParaRPr lang="en-US" sz="1200" dirty="0"/>
-          </a:p>
-        </p:txBody>
-      </p:sp>
-      <p:sp>
-        <p:nvSpPr>
-          <p:cNvPr id="20" name="Text 18"/>
-          <p:cNvSpPr txBox="1"/>
-          <p:nvPr/>
-        </p:nvSpPr>
-        <p:spPr>
-          <a:xfrm>
-            <a:off x="9052560" y="4142232"/>
-            <a:ext cx="2514600" cy="365760"/>
-          </a:xfrm>
-          <a:prstGeom prst="rect">
-            <a:avLst/>
-          </a:prstGeom>
-          <a:noFill/>
-          <a:ln/>
-        </p:spPr>
-        <p:txBody>
-          <a:bodyPr wrap="square" lIns="0" tIns="0" rIns="0" bIns="0" rtlCol="0" anchor="ctr"/>
-          <a:lstStyle/>
-          <a:p>
-            <a:pPr indent="0" marL="0">
-              <a:buNone/>
-            </a:pPr>
-            <a:r>
-              <a:rPr lang="en-US" sz="1200" b="1" spc="100" kern="0" dirty="0">
-                <a:solidFill>
-                  <a:srgbClr val="5FD4C7"/>
-                </a:solidFill>
-                <a:latin typeface="Calibri" pitchFamily="34" charset="0"/>
-                <a:ea typeface="Calibri" pitchFamily="34" charset="-122"/>
-                <a:cs typeface="Calibri" pitchFamily="34" charset="-120"/>
-              </a:rPr>
-              <a:t>SAFETY FLOOR</a:t>
-            </a:r>
-            <a:endParaRPr lang="en-US" sz="1200" dirty="0"/>
-          </a:p>
-        </p:txBody>
-      </p:sp>
-      <p:sp>
-        <p:nvSpPr>
-          <p:cNvPr id="21" name="Text 19"/>
-          <p:cNvSpPr txBox="1"/>
-          <p:nvPr/>
-        </p:nvSpPr>
-        <p:spPr>
-          <a:xfrm>
-            <a:off x="8458200" y="4663440"/>
-            <a:ext cx="3063240" cy="731520"/>
-          </a:xfrm>
-          <a:prstGeom prst="rect">
-            <a:avLst/>
-          </a:prstGeom>
-          <a:noFill/>
-          <a:ln/>
-        </p:spPr>
-        <p:txBody>
-          <a:bodyPr wrap="square" lIns="0" tIns="0" rIns="0" bIns="0" rtlCol="0" anchor="t"/>
-          <a:lstStyle/>
-          <a:p>
-            <a:pPr indent="0" marL="0">
-              <a:buNone/>
-            </a:pPr>
-            <a:r>
-              <a:rPr lang="en-US" sz="1150" dirty="0">
-                <a:solidFill>
-                  <a:srgbClr val="D7E1F0"/>
-                </a:solidFill>
-                <a:latin typeface="Calibri" pitchFamily="34" charset="0"/>
-                <a:ea typeface="Calibri" pitchFamily="34" charset="-122"/>
-                <a:cs typeface="Calibri" pitchFamily="34" charset="-120"/>
-              </a:rPr>
-              <a:t>Bypasses AI entirely in medical emergencies via a &lt; 20 ms short-circuit.</a:t>
             </a:r>
             <a:endParaRPr lang="en-US" sz="1150" dirty="0"/>
           </a:p>
@@ -3578,7 +3244,7 @@
               </a:defRPr>
             </a:pPr>
             <a:r>
-              <a:t>Milestone: Design Document &amp; Feasibility Analysis  ·  FastAPI · PostgreSQL (pgvector) · React · Clerk</a:t>
+              <a:t>Milestone: Design Document &amp; Feasibility Analysis  ·  Full stack deployed &amp; running  ·  FastAPI · PostgreSQL · React · Clerk</a:t>
             </a:r>
           </a:p>
         </p:txBody>
@@ -3591,8 +3257,8 @@
         </p:nvSpPr>
         <p:spPr>
           <a:xfrm>
-            <a:off x="640080" y="3180000"/>
-            <a:ext cx="5600000" cy="548640"/>
+            <a:off x="4434840" y="3886200"/>
+            <a:ext cx="7315200" cy="1691640"/>
           </a:xfrm>
           <a:prstGeom prst="roundRect">
             <a:avLst/>
@@ -3600,7 +3266,7 @@
           <a:solidFill>
             <a:srgbClr val="22335A"/>
           </a:solidFill>
-          <a:ln w="12700">
+          <a:ln w="19050">
             <a:solidFill>
               <a:srgbClr val="3B4F7A"/>
             </a:solidFill>
@@ -3630,81 +3296,23 @@
       </p:sp>
       <p:sp>
         <p:nvSpPr>
-          <p:cNvPr id="25" name="TextBox 24"/>
-          <p:cNvSpPr txBox="1"/>
-          <p:nvPr/>
-        </p:nvSpPr>
-        <p:spPr>
-          <a:xfrm>
-            <a:off x="800000" y="3210000"/>
-            <a:ext cx="5300000" cy="480000"/>
-          </a:xfrm>
-          <a:prstGeom prst="rect">
-            <a:avLst/>
-          </a:prstGeom>
-          <a:noFill/>
-        </p:spPr>
-        <p:txBody>
-          <a:bodyPr wrap="square">
-            <a:spAutoFit/>
-          </a:bodyPr>
-          <a:lstStyle/>
-          <a:p>
-            <a:r>
-              <a:rPr sz="1350" b="1">
-                <a:solidFill>
-                  <a:srgbClr val="FFFFFF"/>
-                </a:solidFill>
-                <a:latin typeface="Cambria"/>
-              </a:rPr>
-              <a:t>Shardul Shripad Hingane</a:t>
-            </a:r>
-            <a:r>
-              <a:rPr sz="1100">
-                <a:solidFill>
-                  <a:srgbClr val="0F8B8D"/>
-                </a:solidFill>
-                <a:latin typeface="Calibri"/>
-              </a:rPr>
-              <a:t>  (Reg: 2023bit005)</a:t>
-            </a:r>
-          </a:p>
-          <a:p>
-            <a:pPr>
-              <a:defRPr sz="1100">
-                <a:solidFill>
-                  <a:srgbClr val="CBD5E1"/>
-                </a:solidFill>
-                <a:latin typeface="Calibri"/>
-              </a:defRPr>
-            </a:pPr>
-            <a:r>
-              <a:t>Department of Information Technology</a:t>
-            </a:r>
-          </a:p>
-        </p:txBody>
-      </p:sp>
-      <p:sp>
-        <p:nvSpPr>
-          <p:cNvPr id="26" name="Rounded Rectangle 25"/>
+          <p:cNvPr id="25" name="Oval 24"/>
           <p:cNvSpPr/>
           <p:nvPr/>
         </p:nvSpPr>
         <p:spPr>
           <a:xfrm>
-            <a:off x="6440080" y="3180000"/>
-            <a:ext cx="5081360" cy="548640"/>
-          </a:xfrm>
-          <a:prstGeom prst="roundRect">
+            <a:off x="4680000" y="4114800"/>
+            <a:ext cx="457200" cy="457200"/>
+          </a:xfrm>
+          <a:prstGeom prst="ellipse">
             <a:avLst/>
           </a:prstGeom>
           <a:solidFill>
-            <a:srgbClr val="22335A"/>
+            <a:srgbClr val="0F8B8D"/>
           </a:solidFill>
-          <a:ln w="12700">
-            <a:solidFill>
-              <a:srgbClr val="3B4F7A"/>
-            </a:solidFill>
+          <a:ln>
+            <a:noFill/>
           </a:ln>
         </p:spPr>
         <p:style>
@@ -3731,14 +3339,50 @@
       </p:sp>
       <p:sp>
         <p:nvSpPr>
+          <p:cNvPr id="26" name="TextBox 25"/>
+          <p:cNvSpPr txBox="1"/>
+          <p:nvPr/>
+        </p:nvSpPr>
+        <p:spPr>
+          <a:xfrm>
+            <a:off x="4680000" y="4114800"/>
+            <a:ext cx="457200" cy="457200"/>
+          </a:xfrm>
+          <a:prstGeom prst="rect">
+            <a:avLst/>
+          </a:prstGeom>
+          <a:noFill/>
+        </p:spPr>
+        <p:txBody>
+          <a:bodyPr wrap="none">
+            <a:spAutoFit/>
+          </a:bodyPr>
+          <a:lstStyle/>
+          <a:p>
+            <a:pPr algn="ctr">
+              <a:defRPr sz="1300" b="1">
+                <a:solidFill>
+                  <a:srgbClr val="FFFFFF"/>
+                </a:solidFill>
+                <a:latin typeface="Cambria"/>
+              </a:defRPr>
+            </a:pPr>
+            <a:r>
+              <a:t>IT</a:t>
+            </a:r>
+          </a:p>
+        </p:txBody>
+      </p:sp>
+      <p:sp>
+        <p:nvSpPr>
           <p:cNvPr id="27" name="TextBox 26"/>
           <p:cNvSpPr txBox="1"/>
           <p:nvPr/>
         </p:nvSpPr>
         <p:spPr>
           <a:xfrm>
-            <a:off x="6600000" y="3210000"/>
-            <a:ext cx="4800000" cy="480000"/>
+            <a:off x="5250000" y="4000000"/>
+            <a:ext cx="2750000" cy="1500000"/>
           </a:xfrm>
           <a:prstGeom prst="rect">
             <a:avLst/>
@@ -3751,36 +3395,288 @@
           </a:bodyPr>
           <a:lstStyle/>
           <a:p>
-            <a:r>
-              <a:rPr sz="1100">
-                <a:solidFill>
-                  <a:srgbClr val="94A3B8"/>
-                </a:solidFill>
-                <a:latin typeface="Calibri"/>
-              </a:rPr>
-              <a:t>Project Guide: </a:t>
-            </a:r>
-            <a:r>
-              <a:rPr sz="1350" b="1">
-                <a:solidFill>
-                  <a:srgbClr val="FFFFFF"/>
-                </a:solidFill>
-                <a:latin typeface="Cambria"/>
-              </a:rPr>
-              <a:t>C.P. Navdeti</a:t>
-            </a:r>
-          </a:p>
-          <a:p>
             <a:pPr>
-              <a:defRPr sz="1100">
-                <a:solidFill>
-                  <a:srgbClr val="CBD5E1"/>
+              <a:defRPr sz="1000" b="1">
+                <a:solidFill>
+                  <a:srgbClr val="0F8B8D"/>
                 </a:solidFill>
                 <a:latin typeface="Calibri"/>
               </a:defRPr>
             </a:pPr>
             <a:r>
-              <a:t>Evaluation Date: 26 Sep 2026</a:t>
+              <a:t>PROJECT CANDIDATE</a:t>
+            </a:r>
+          </a:p>
+          <a:p>
+            <a:pPr>
+              <a:spcBef>
+                <a:spcPts val="300"/>
+              </a:spcBef>
+            </a:pPr>
+            <a:r>
+              <a:rPr sz="1600" b="1">
+                <a:solidFill>
+                  <a:srgbClr val="FFFFFF"/>
+                </a:solidFill>
+                <a:latin typeface="Cambria"/>
+              </a:rPr>
+              <a:t>Shardul Shripad Hingane</a:t>
+            </a:r>
+          </a:p>
+          <a:p>
+            <a:pPr>
+              <a:spcBef>
+                <a:spcPts val="400"/>
+              </a:spcBef>
+            </a:pPr>
+            <a:r>
+              <a:rPr sz="1100">
+                <a:solidFill>
+                  <a:srgbClr val="94A3B8"/>
+                </a:solidFill>
+                <a:latin typeface="Calibri"/>
+              </a:rPr>
+              <a:t>Registration No: </a:t>
+            </a:r>
+            <a:r>
+              <a:rPr sz="1100" b="1">
+                <a:solidFill>
+                  <a:srgbClr val="0F8B8D"/>
+                </a:solidFill>
+                <a:latin typeface="Calibri"/>
+              </a:rPr>
+              <a:t>2023bit005</a:t>
+            </a:r>
+          </a:p>
+          <a:p>
+            <a:pPr>
+              <a:spcBef>
+                <a:spcPts val="200"/>
+              </a:spcBef>
+            </a:pPr>
+            <a:r>
+              <a:rPr sz="1100">
+                <a:solidFill>
+                  <a:srgbClr val="CBD5E1"/>
+                </a:solidFill>
+                <a:latin typeface="Calibri"/>
+              </a:rPr>
+              <a:t>Department of Information Technology</a:t>
+            </a:r>
+          </a:p>
+        </p:txBody>
+      </p:sp>
+      <p:sp>
+        <p:nvSpPr>
+          <p:cNvPr id="28" name="Rectangle 27"/>
+          <p:cNvSpPr/>
+          <p:nvPr/>
+        </p:nvSpPr>
+        <p:spPr>
+          <a:xfrm>
+            <a:off x="8050000" y="4050000"/>
+            <a:ext cx="20000" cy="1350000"/>
+          </a:xfrm>
+          <a:prstGeom prst="rect">
+            <a:avLst/>
+          </a:prstGeom>
+          <a:solidFill>
+            <a:srgbClr val="3B4F7A"/>
+          </a:solidFill>
+          <a:ln>
+            <a:noFill/>
+          </a:ln>
+        </p:spPr>
+        <p:style>
+          <a:lnRef idx="1">
+            <a:schemeClr val="accent1"/>
+          </a:lnRef>
+          <a:fillRef idx="3">
+            <a:schemeClr val="accent1"/>
+          </a:fillRef>
+          <a:effectRef idx="2">
+            <a:schemeClr val="accent1"/>
+          </a:effectRef>
+          <a:fontRef idx="minor">
+            <a:schemeClr val="lt1"/>
+          </a:fontRef>
+        </p:style>
+        <p:txBody>
+          <a:bodyPr rtlCol="0" anchor="ctr"/>
+          <a:lstStyle/>
+          <a:p>
+            <a:pPr algn="ctr"/>
+          </a:p>
+        </p:txBody>
+      </p:sp>
+      <p:sp>
+        <p:nvSpPr>
+          <p:cNvPr id="29" name="Oval 28"/>
+          <p:cNvSpPr/>
+          <p:nvPr/>
+        </p:nvSpPr>
+        <p:spPr>
+          <a:xfrm>
+            <a:off x="8250000" y="4114800"/>
+            <a:ext cx="457200" cy="457200"/>
+          </a:xfrm>
+          <a:prstGeom prst="ellipse">
+            <a:avLst/>
+          </a:prstGeom>
+          <a:solidFill>
+            <a:srgbClr val="0F8B8D"/>
+          </a:solidFill>
+          <a:ln>
+            <a:noFill/>
+          </a:ln>
+        </p:spPr>
+        <p:style>
+          <a:lnRef idx="1">
+            <a:schemeClr val="accent1"/>
+          </a:lnRef>
+          <a:fillRef idx="3">
+            <a:schemeClr val="accent1"/>
+          </a:fillRef>
+          <a:effectRef idx="2">
+            <a:schemeClr val="accent1"/>
+          </a:effectRef>
+          <a:fontRef idx="minor">
+            <a:schemeClr val="lt1"/>
+          </a:fontRef>
+        </p:style>
+        <p:txBody>
+          <a:bodyPr rtlCol="0" anchor="ctr"/>
+          <a:lstStyle/>
+          <a:p>
+            <a:pPr algn="ctr"/>
+          </a:p>
+        </p:txBody>
+      </p:sp>
+      <p:sp>
+        <p:nvSpPr>
+          <p:cNvPr id="30" name="TextBox 29"/>
+          <p:cNvSpPr txBox="1"/>
+          <p:nvPr/>
+        </p:nvSpPr>
+        <p:spPr>
+          <a:xfrm>
+            <a:off x="8250000" y="4114800"/>
+            <a:ext cx="457200" cy="457200"/>
+          </a:xfrm>
+          <a:prstGeom prst="rect">
+            <a:avLst/>
+          </a:prstGeom>
+          <a:noFill/>
+        </p:spPr>
+        <p:txBody>
+          <a:bodyPr wrap="none">
+            <a:spAutoFit/>
+          </a:bodyPr>
+          <a:lstStyle/>
+          <a:p>
+            <a:pPr algn="ctr">
+              <a:defRPr sz="1300" b="1">
+                <a:solidFill>
+                  <a:srgbClr val="FFFFFF"/>
+                </a:solidFill>
+                <a:latin typeface="Cambria"/>
+              </a:defRPr>
+            </a:pPr>
+            <a:r>
+              <a:t>PG</a:t>
+            </a:r>
+          </a:p>
+        </p:txBody>
+      </p:sp>
+      <p:sp>
+        <p:nvSpPr>
+          <p:cNvPr id="31" name="TextBox 30"/>
+          <p:cNvSpPr txBox="1"/>
+          <p:nvPr/>
+        </p:nvSpPr>
+        <p:spPr>
+          <a:xfrm>
+            <a:off x="8820000" y="4000000"/>
+            <a:ext cx="2850000" cy="1500000"/>
+          </a:xfrm>
+          <a:prstGeom prst="rect">
+            <a:avLst/>
+          </a:prstGeom>
+          <a:noFill/>
+        </p:spPr>
+        <p:txBody>
+          <a:bodyPr wrap="square">
+            <a:spAutoFit/>
+          </a:bodyPr>
+          <a:lstStyle/>
+          <a:p>
+            <a:pPr>
+              <a:defRPr sz="1000" b="1">
+                <a:solidFill>
+                  <a:srgbClr val="0F8B8D"/>
+                </a:solidFill>
+                <a:latin typeface="Calibri"/>
+              </a:defRPr>
+            </a:pPr>
+            <a:r>
+              <a:t>PROJECT SUPERVISION</a:t>
+            </a:r>
+          </a:p>
+          <a:p>
+            <a:pPr>
+              <a:spcBef>
+                <a:spcPts val="300"/>
+              </a:spcBef>
+            </a:pPr>
+            <a:r>
+              <a:rPr sz="1600" b="1">
+                <a:solidFill>
+                  <a:srgbClr val="FFFFFF"/>
+                </a:solidFill>
+                <a:latin typeface="Cambria"/>
+              </a:rPr>
+              <a:t>C.P. Navdeti</a:t>
+            </a:r>
+          </a:p>
+          <a:p>
+            <a:pPr>
+              <a:spcBef>
+                <a:spcPts val="400"/>
+              </a:spcBef>
+            </a:pPr>
+            <a:r>
+              <a:rPr sz="1100">
+                <a:solidFill>
+                  <a:srgbClr val="94A3B8"/>
+                </a:solidFill>
+                <a:latin typeface="Calibri"/>
+              </a:rPr>
+              <a:t>Project Guide  ·  Dept of IT</a:t>
+            </a:r>
+          </a:p>
+          <a:p>
+            <a:pPr>
+              <a:spcBef>
+                <a:spcPts val="200"/>
+              </a:spcBef>
+            </a:pPr>
+            <a:r>
+              <a:rPr sz="1100">
+                <a:solidFill>
+                  <a:srgbClr val="94A3B8"/>
+                </a:solidFill>
+                <a:latin typeface="Calibri"/>
+              </a:rPr>
+              <a:t>Evaluation Date: </a:t>
+            </a:r>
+            <a:r>
+              <a:rPr sz="1100" b="1">
+                <a:solidFill>
+                  <a:srgbClr val="0F8B8D"/>
+                </a:solidFill>
+                <a:latin typeface="Calibri"/>
+              </a:rPr>
+              <a:t>26 Sep 2026</a:t>
             </a:r>
           </a:p>
         </p:txBody>

</xml_diff>